<commit_message>
fix: harden feature importance insights
</commit_message>
<xml_diff>
--- a/data/model/random-forest-feature-importance.pptx
+++ b/data/model/random-forest-feature-importance.pptx
@@ -3302,7 +3302,7 @@
         </p:nvSpPr>
         <p:spPr>
           <a:xfrm>
-            <a:off x="7022592" y="1417320"/>
+            <a:off x="7013448" y="1417320"/>
             <a:ext cx="978408" cy="329184"/>
           </a:xfrm>
           <a:prstGeom prst="rect">
@@ -3419,7 +3419,7 @@
         </p:nvSpPr>
         <p:spPr>
           <a:xfrm>
-            <a:off x="7022592" y="2148840"/>
+            <a:off x="5409090" y="2148840"/>
             <a:ext cx="978408" cy="329184"/>
           </a:xfrm>
           <a:prstGeom prst="rect">
@@ -3536,7 +3536,7 @@
         </p:nvSpPr>
         <p:spPr>
           <a:xfrm>
-            <a:off x="7022592" y="2880360"/>
+            <a:off x="4406558" y="2880360"/>
             <a:ext cx="978408" cy="329184"/>
           </a:xfrm>
           <a:prstGeom prst="rect">
@@ -3653,7 +3653,7 @@
         </p:nvSpPr>
         <p:spPr>
           <a:xfrm>
-            <a:off x="7022592" y="3611880"/>
+            <a:off x="4080760" y="3611880"/>
             <a:ext cx="978408" cy="329184"/>
           </a:xfrm>
           <a:prstGeom prst="rect">
@@ -3770,7 +3770,7 @@
         </p:nvSpPr>
         <p:spPr>
           <a:xfrm>
-            <a:off x="7022592" y="4343400"/>
+            <a:off x="3299509" y="4343400"/>
             <a:ext cx="978408" cy="329184"/>
           </a:xfrm>
           <a:prstGeom prst="rect">
@@ -3887,7 +3887,7 @@
         </p:nvSpPr>
         <p:spPr>
           <a:xfrm>
-            <a:off x="7022592" y="5074920"/>
+            <a:off x="2957971" y="5074920"/>
             <a:ext cx="978408" cy="329184"/>
           </a:xfrm>
           <a:prstGeom prst="rect">

</xml_diff>